<commit_message>
docs(demo): add lavender title background and new stickers to the deck
</commit_message>
<xml_diff>
--- a/demo/presentation.pptx
+++ b/demo/presentation.pptx
@@ -118,19 +118,19 @@
   <p:extLst>
     <p:ext uri="{521415D9-36F7-43E2-AB2F-B90AF26B5E84}">
       <p14:sectionLst xmlns:p14="http://schemas.microsoft.com/office/powerpoint/2010/main">
-        <p14:section name="Intro" id="{ea82aad8-eace-817a-e826-f5ef4942f8d8}">
+        <p14:section name="Intro" id="{a51aebf7-cf75-fd11-763e-6af36913c8c8}">
           <p14:sldIdLst>
             <p14:sldId id="256"/>
             <p14:sldId id="257"/>
           </p14:sldIdLst>
         </p14:section>
-        <p14:section name="Product" id="{3e4ffd33-3775-1402-5659-ebd601980f85}">
+        <p14:section name="Product" id="{81215416-cdc0-9824-b11a-e902a1e92ae8}">
           <p14:sldIdLst>
             <p14:sldId id="258"/>
             <p14:sldId id="259"/>
           </p14:sldIdLst>
         </p14:section>
-        <p14:section name="Platform" id="{d515bc55-4d09-ba86-a88d-d48ed067225d}">
+        <p14:section name="Platform" id="{8dab6386-c7f0-2a1b-1293-33d0cce0a436}">
           <p14:sldIdLst>
             <p14:sldId id="260"/>
             <p14:sldId id="261"/>
@@ -138,13 +138,13 @@
             <p14:sldId id="263"/>
           </p14:sldIdLst>
         </p14:section>
-        <p14:section name="Operate" id="{fe4c08f0-b5c7-e501-a23c-96bf5868ab29}">
+        <p14:section name="Operate" id="{6716a67f-a58a-74ca-298a-1ebb1b2aac2f}">
           <p14:sldIdLst>
             <p14:sldId id="264"/>
             <p14:sldId id="265"/>
           </p14:sldIdLst>
         </p14:section>
-        <p14:section name="Wrap up" id="{a56bdc31-f575-acb6-3f2b-e7cb215545dc}">
+        <p14:section name="Wrap up" id="{71517370-95ab-0597-24c6-5846a1cf4bcd}">
           <p14:sldIdLst>
             <p14:sldId id="266"/>
             <p14:sldId id="267"/>
@@ -2315,6 +2315,20 @@
 <file path=ppt/slides/slide1.xml><?xml version="1.0" encoding="utf-8"?>
 <p:sld xmlns:a="http://schemas.openxmlformats.org/drawingml/2006/main" xmlns:r="http://schemas.openxmlformats.org/officeDocument/2006/relationships" xmlns:p="http://schemas.openxmlformats.org/presentationml/2006/main">
   <p:cSld name="Slide 1">
+    <p:bg>
+      <p:bgPr>
+        <a:blipFill dpi="0" rotWithShape="1">
+          <a:blip r:embed="rId1">
+            <a:lum/>
+          </a:blip>
+          <a:srcRect/>
+          <a:stretch>
+            <a:fillRect/>
+          </a:stretch>
+        </a:blipFill>
+        <a:effectLst/>
+      </p:bgPr>
+    </p:bg>
     <p:spTree>
       <p:nvGrpSpPr>
         <p:cNvPr id="1" name=""/>
@@ -2331,13 +2345,42 @@
       </p:grpSpPr>
       <p:sp>
         <p:nvSpPr>
-          <p:cNvPr id="2" name="Logo"/>
+          <p:cNvPr id="2" name="Frosted panel"/>
           <p:cNvSpPr/>
           <p:nvPr/>
         </p:nvSpPr>
         <p:spPr>
           <a:xfrm>
-            <a:off x="685800" y="685800"/>
+            <a:off x="411480" y="411480"/>
+            <a:ext cx="5989320" cy="6035040"/>
+          </a:xfrm>
+          <a:prstGeom prst="roundRect">
+            <a:avLst>
+              <a:gd name="adj" fmla="val 4580"/>
+            </a:avLst>
+          </a:prstGeom>
+          <a:solidFill>
+            <a:srgbClr val="FFFFFF">
+              <a:alpha val="55000"/>
+            </a:srgbClr>
+          </a:solidFill>
+          <a:ln w="12700">
+            <a:solidFill>
+              <a:srgbClr val="FFFFFF"/>
+            </a:solidFill>
+            <a:prstDash val="solid"/>
+          </a:ln>
+        </p:spPr>
+      </p:sp>
+      <p:sp>
+        <p:nvSpPr>
+          <p:cNvPr id="3" name="Logo"/>
+          <p:cNvSpPr/>
+          <p:nvPr/>
+        </p:nvSpPr>
+        <p:spPr>
+          <a:xfrm>
+            <a:off x="777240" y="777240"/>
             <a:ext cx="623621" cy="271577"/>
           </a:xfrm>
           <a:prstGeom prst="roundRect">
@@ -2358,13 +2401,13 @@
       </p:sp>
       <p:sp>
         <p:nvSpPr>
-          <p:cNvPr id="3" name="Logo"/>
+          <p:cNvPr id="4" name="Logo"/>
           <p:cNvSpPr/>
           <p:nvPr/>
         </p:nvSpPr>
         <p:spPr>
           <a:xfrm>
-            <a:off x="685800" y="685800"/>
+            <a:off x="777240" y="777240"/>
             <a:ext cx="271577" cy="754380"/>
           </a:xfrm>
           <a:prstGeom prst="roundRect">
@@ -2385,13 +2428,13 @@
       </p:sp>
       <p:sp>
         <p:nvSpPr>
-          <p:cNvPr id="4" name="Logo"/>
+          <p:cNvPr id="5" name="Logo"/>
           <p:cNvSpPr/>
           <p:nvPr/>
         </p:nvSpPr>
         <p:spPr>
           <a:xfrm>
-            <a:off x="685800" y="997610"/>
+            <a:off x="777240" y="1089050"/>
             <a:ext cx="271577" cy="442570"/>
           </a:xfrm>
           <a:prstGeom prst="roundRect">
@@ -2412,13 +2455,13 @@
       </p:sp>
       <p:sp>
         <p:nvSpPr>
-          <p:cNvPr id="5" name="Logo"/>
+          <p:cNvPr id="6" name="Logo"/>
           <p:cNvSpPr/>
           <p:nvPr/>
         </p:nvSpPr>
         <p:spPr>
           <a:xfrm>
-            <a:off x="1017727" y="1037844"/>
+            <a:off x="1109167" y="1129284"/>
             <a:ext cx="231343" cy="231343"/>
           </a:xfrm>
           <a:prstGeom prst="ellipse">
@@ -2437,14 +2480,14 @@
       </p:sp>
       <p:sp>
         <p:nvSpPr>
-          <p:cNvPr id="6" name="Title"/>
-          <p:cNvSpPr txBox="1"/>
-          <p:nvPr/>
-        </p:nvSpPr>
-        <p:spPr>
-          <a:xfrm>
-            <a:off x="640080" y="1691640"/>
-            <a:ext cx="5943600" cy="1463040"/>
+          <p:cNvPr id="7" name="Title"/>
+          <p:cNvSpPr txBox="1"/>
+          <p:nvPr/>
+        </p:nvSpPr>
+        <p:spPr>
+          <a:xfrm>
+            <a:off x="731520" y="1783080"/>
+            <a:ext cx="5486400" cy="1371600"/>
           </a:xfrm>
           <a:prstGeom prst="rect">
             <a:avLst/>
@@ -2460,9 +2503,9 @@
               <a:buNone/>
             </a:pPr>
             <a:r>
-              <a:rPr lang="en-US" sz="9600" b="1" dirty="0">
-                <a:solidFill>
-                  <a:srgbClr val="FFFFFF"/>
+              <a:rPr lang="en-US" sz="9200" b="1" dirty="0">
+                <a:solidFill>
+                  <a:srgbClr val="1B1A24"/>
                 </a:solidFill>
                 <a:latin typeface="Roboto Mono" pitchFamily="34" charset="0"/>
                 <a:ea typeface="Roboto Mono" pitchFamily="34" charset="-122"/>
@@ -2470,20 +2513,20 @@
               </a:rPr>
               <a:t>Fellow</a:t>
             </a:r>
-            <a:endParaRPr lang="en-US" sz="9600" dirty="0"/>
-          </a:p>
-        </p:txBody>
-      </p:sp>
-      <p:sp>
-        <p:nvSpPr>
-          <p:cNvPr id="7" name="Text 5"/>
-          <p:cNvSpPr txBox="1"/>
-          <p:nvPr/>
-        </p:nvSpPr>
-        <p:spPr>
-          <a:xfrm>
-            <a:off x="685800" y="3108960"/>
-            <a:ext cx="5943600" cy="548640"/>
+            <a:endParaRPr lang="en-US" sz="9200" dirty="0"/>
+          </a:p>
+        </p:txBody>
+      </p:sp>
+      <p:sp>
+        <p:nvSpPr>
+          <p:cNvPr id="8" name="Text 6"/>
+          <p:cNvSpPr txBox="1"/>
+          <p:nvPr/>
+        </p:nvSpPr>
+        <p:spPr>
+          <a:xfrm>
+            <a:off x="777240" y="3154680"/>
+            <a:ext cx="5486400" cy="502920"/>
           </a:xfrm>
           <a:prstGeom prst="rect">
             <a:avLst/>
@@ -2499,9 +2542,9 @@
               <a:buNone/>
             </a:pPr>
             <a:r>
-              <a:rPr lang="en-US" sz="2000" dirty="0">
-                <a:solidFill>
-                  <a:srgbClr val="FFBDC5"/>
+              <a:rPr lang="en-US" sz="2000" b="1" dirty="0">
+                <a:solidFill>
+                  <a:srgbClr val="4B3BA0"/>
                 </a:solidFill>
                 <a:latin typeface="Roboto Mono" pitchFamily="34" charset="0"/>
                 <a:ea typeface="Roboto Mono" pitchFamily="34" charset="-122"/>
@@ -2515,14 +2558,14 @@
       </p:sp>
       <p:sp>
         <p:nvSpPr>
-          <p:cNvPr id="8" name="Text 6"/>
-          <p:cNvSpPr txBox="1"/>
-          <p:nvPr/>
-        </p:nvSpPr>
-        <p:spPr>
-          <a:xfrm>
-            <a:off x="685800" y="3840480"/>
-            <a:ext cx="5394960" cy="914400"/>
+          <p:cNvPr id="9" name="Text 7"/>
+          <p:cNvSpPr txBox="1"/>
+          <p:nvPr/>
+        </p:nvSpPr>
+        <p:spPr>
+          <a:xfrm>
+            <a:off x="777240" y="3840480"/>
+            <a:ext cx="5303520" cy="914400"/>
           </a:xfrm>
           <a:prstGeom prst="rect">
             <a:avLst/>
@@ -2540,7 +2583,7 @@
             <a:r>
               <a:rPr lang="en-US" sz="1500" dirty="0">
                 <a:solidFill>
-                  <a:srgbClr val="AEB8C8"/>
+                  <a:srgbClr val="1B1A24"/>
                 </a:solidFill>
               </a:rPr>
               <a:t>From a React screen to a monitored Kubernetes deployment: tested, scanned, containerised, provisioned with Terraform and delivered through GitOps.</a:t>
@@ -2551,13 +2594,13 @@
       </p:sp>
       <p:sp>
         <p:nvSpPr>
-          <p:cNvPr id="9" name="Text 7"/>
-          <p:cNvSpPr txBox="1"/>
-          <p:nvPr/>
-        </p:nvSpPr>
-        <p:spPr>
-          <a:xfrm>
-            <a:off x="685800" y="5257800"/>
+          <p:cNvPr id="10" name="Text 8"/>
+          <p:cNvSpPr txBox="1"/>
+          <p:nvPr/>
+        </p:nvSpPr>
+        <p:spPr>
+          <a:xfrm>
+            <a:off x="777240" y="5166360"/>
             <a:ext cx="1920240" cy="347472"/>
           </a:xfrm>
           <a:prstGeom prst="roundRect">
@@ -2566,11 +2609,11 @@
             </a:avLst>
           </a:prstGeom>
           <a:solidFill>
-            <a:srgbClr val="2A3850"/>
+            <a:srgbClr val="1F2A3C"/>
           </a:solidFill>
           <a:ln>
             <a:solidFill>
-              <a:srgbClr val="2A3850"/>
+              <a:srgbClr val="1F2A3C"/>
             </a:solidFill>
           </a:ln>
         </p:spPr>
@@ -2584,7 +2627,7 @@
             <a:r>
               <a:rPr lang="en-US" sz="1100" b="1" dirty="0">
                 <a:solidFill>
-                  <a:srgbClr val="FFBDC5"/>
+                  <a:srgbClr val="FFFFFF"/>
                 </a:solidFill>
                 <a:latin typeface="Calibri" pitchFamily="34" charset="0"/>
                 <a:ea typeface="Calibri" pitchFamily="34" charset="-122"/>
@@ -2598,13 +2641,13 @@
       </p:sp>
       <p:sp>
         <p:nvSpPr>
-          <p:cNvPr id="10" name="Text 8"/>
-          <p:cNvSpPr txBox="1"/>
-          <p:nvPr/>
-        </p:nvSpPr>
-        <p:spPr>
-          <a:xfrm>
-            <a:off x="2724912" y="5257800"/>
+          <p:cNvPr id="11" name="Text 9"/>
+          <p:cNvSpPr txBox="1"/>
+          <p:nvPr/>
+        </p:nvSpPr>
+        <p:spPr>
+          <a:xfrm>
+            <a:off x="2816352" y="5166360"/>
             <a:ext cx="1143000" cy="347472"/>
           </a:xfrm>
           <a:prstGeom prst="roundRect">
@@ -2613,11 +2656,11 @@
             </a:avLst>
           </a:prstGeom>
           <a:solidFill>
-            <a:srgbClr val="2A3850"/>
+            <a:srgbClr val="1F2A3C"/>
           </a:solidFill>
           <a:ln>
             <a:solidFill>
-              <a:srgbClr val="2A3850"/>
+              <a:srgbClr val="1F2A3C"/>
             </a:solidFill>
           </a:ln>
         </p:spPr>
@@ -2631,7 +2674,7 @@
             <a:r>
               <a:rPr lang="en-US" sz="1100" b="1" dirty="0">
                 <a:solidFill>
-                  <a:srgbClr val="FFBDC5"/>
+                  <a:srgbClr val="FFFFFF"/>
                 </a:solidFill>
                 <a:latin typeface="Calibri" pitchFamily="34" charset="0"/>
                 <a:ea typeface="Calibri" pitchFamily="34" charset="-122"/>
@@ -2645,13 +2688,13 @@
       </p:sp>
       <p:sp>
         <p:nvSpPr>
-          <p:cNvPr id="11" name="Text 9"/>
-          <p:cNvSpPr txBox="1"/>
-          <p:nvPr/>
-        </p:nvSpPr>
-        <p:spPr>
-          <a:xfrm>
-            <a:off x="685800" y="5806440"/>
+          <p:cNvPr id="12" name="Text 10"/>
+          <p:cNvSpPr txBox="1"/>
+          <p:nvPr/>
+        </p:nvSpPr>
+        <p:spPr>
+          <a:xfrm>
+            <a:off x="777240" y="5715000"/>
             <a:ext cx="4572000" cy="365760"/>
           </a:xfrm>
           <a:prstGeom prst="rect">
@@ -2670,7 +2713,7 @@
             <a:r>
               <a:rPr lang="en-US" sz="1600" b="1" dirty="0">
                 <a:solidFill>
-                  <a:srgbClr val="FFFFFF"/>
+                  <a:srgbClr val="1B1A24"/>
                 </a:solidFill>
               </a:rPr>
               <a:t>Manasvi Sabbarwal</a:t>
@@ -2681,26 +2724,26 @@
       </p:sp>
       <p:sp>
         <p:nvSpPr>
-          <p:cNvPr id="12" name="Browser frame"/>
+          <p:cNvPr id="13" name="Browser frame"/>
           <p:cNvSpPr/>
           <p:nvPr/>
         </p:nvSpPr>
         <p:spPr>
           <a:xfrm>
-            <a:off x="6510528" y="1088136"/>
-            <a:ext cx="5266944" cy="2962656"/>
+            <a:off x="6739128" y="1088136"/>
+            <a:ext cx="5084064" cy="2871216"/>
           </a:xfrm>
           <a:prstGeom prst="roundRect">
             <a:avLst>
-              <a:gd name="adj" fmla="val 4321"/>
+              <a:gd name="adj" fmla="val 4459"/>
             </a:avLst>
           </a:prstGeom>
           <a:solidFill>
-            <a:srgbClr val="0F1622"/>
+            <a:srgbClr val="F4F3F6"/>
           </a:solidFill>
           <a:ln w="9525">
             <a:solidFill>
-              <a:srgbClr val="0F1622"/>
+              <a:srgbClr val="E6E3EA"/>
             </a:solidFill>
             <a:prstDash val="solid"/>
           </a:ln>
@@ -2715,49 +2758,24 @@
       </p:sp>
       <p:sp>
         <p:nvSpPr>
-          <p:cNvPr id="13" name="Window dot"/>
-          <p:cNvSpPr/>
-          <p:nvPr/>
-        </p:nvSpPr>
-        <p:spPr>
-          <a:xfrm>
-            <a:off x="6656832" y="1197864"/>
-            <a:ext cx="109728" cy="109728"/>
-          </a:xfrm>
-          <a:prstGeom prst="ellipse">
-            <a:avLst/>
-          </a:prstGeom>
-          <a:solidFill>
-            <a:srgbClr val="FF5F57"/>
-          </a:solidFill>
-          <a:ln w="12700">
-            <a:solidFill>
-              <a:srgbClr val="FF5F57"/>
-            </a:solidFill>
-            <a:prstDash val="solid"/>
-          </a:ln>
-        </p:spPr>
-      </p:sp>
-      <p:sp>
-        <p:nvSpPr>
           <p:cNvPr id="14" name="Window dot"/>
           <p:cNvSpPr/>
           <p:nvPr/>
         </p:nvSpPr>
         <p:spPr>
           <a:xfrm>
-            <a:off x="6839712" y="1197864"/>
+            <a:off x="6885432" y="1197864"/>
             <a:ext cx="109728" cy="109728"/>
           </a:xfrm>
           <a:prstGeom prst="ellipse">
             <a:avLst/>
           </a:prstGeom>
           <a:solidFill>
-            <a:srgbClr val="FEBC2E"/>
+            <a:srgbClr val="FF5F57"/>
           </a:solidFill>
           <a:ln w="12700">
             <a:solidFill>
-              <a:srgbClr val="FEBC2E"/>
+              <a:srgbClr val="FF5F57"/>
             </a:solidFill>
             <a:prstDash val="solid"/>
           </a:ln>
@@ -2771,7 +2789,32 @@
         </p:nvSpPr>
         <p:spPr>
           <a:xfrm>
-            <a:off x="7022592" y="1197864"/>
+            <a:off x="7068312" y="1197864"/>
+            <a:ext cx="109728" cy="109728"/>
+          </a:xfrm>
+          <a:prstGeom prst="ellipse">
+            <a:avLst/>
+          </a:prstGeom>
+          <a:solidFill>
+            <a:srgbClr val="FEBC2E"/>
+          </a:solidFill>
+          <a:ln w="12700">
+            <a:solidFill>
+              <a:srgbClr val="FEBC2E"/>
+            </a:solidFill>
+            <a:prstDash val="solid"/>
+          </a:ln>
+        </p:spPr>
+      </p:sp>
+      <p:sp>
+        <p:nvSpPr>
+          <p:cNvPr id="16" name="Window dot"/>
+          <p:cNvSpPr/>
+          <p:nvPr/>
+        </p:nvSpPr>
+        <p:spPr>
+          <a:xfrm>
+            <a:off x="7251192" y="1197864"/>
             <a:ext cx="109728" cy="109728"/>
           </a:xfrm>
           <a:prstGeom prst="ellipse">
@@ -2790,22 +2833,22 @@
       </p:sp>
       <p:pic>
         <p:nvPicPr>
-          <p:cNvPr id="16" name="Image 0" descr="Screenshot of the running Fellow stack">    </p:cNvPr>
+          <p:cNvPr id="17" name="Image 0" descr="Screenshot of the running Fellow stack">    </p:cNvPr>
           <p:cNvPicPr>
             <a:picLocks noChangeAspect="1"/>
           </p:cNvPicPr>
           <p:nvPr/>
         </p:nvPicPr>
         <p:blipFill>
-          <a:blip r:embed="rId1"/>
+          <a:blip r:embed="rId2"/>
           <a:stretch>
             <a:fillRect/>
           </a:stretch>
         </p:blipFill>
         <p:spPr>
           <a:xfrm>
-            <a:off x="6583680" y="1417320"/>
-            <a:ext cx="5120640" cy="2560320"/>
+            <a:off x="6812280" y="1417320"/>
+            <a:ext cx="4937760" cy="2468880"/>
           </a:xfrm>
           <a:prstGeom prst="rect">
             <a:avLst/>
@@ -2814,18 +2857,18 @@
       </p:pic>
       <p:sp>
         <p:nvSpPr>
-          <p:cNvPr id="17" name="Sticker frame"/>
+          <p:cNvPr id="18" name="Sticker frame"/>
           <p:cNvSpPr/>
           <p:nvPr/>
         </p:nvSpPr>
         <p:spPr>
           <a:xfrm>
-            <a:off x="9738360" y="3246120"/>
-            <a:ext cx="1554480" cy="3063240"/>
+            <a:off x="9966960" y="3291840"/>
+            <a:ext cx="1508760" cy="2971800"/>
           </a:xfrm>
           <a:prstGeom prst="roundRect">
             <a:avLst>
-              <a:gd name="adj" fmla="val 10588"/>
+              <a:gd name="adj" fmla="val 10909"/>
             </a:avLst>
           </a:prstGeom>
           <a:solidFill>
@@ -2848,53 +2891,28 @@
       </p:sp>
       <p:pic>
         <p:nvPicPr>
-          <p:cNvPr id="18" name="Image 1" descr="Illustration">    </p:cNvPr>
+          <p:cNvPr id="19" name="Image 1" descr="Illustration">    </p:cNvPr>
           <p:cNvPicPr>
             <a:picLocks noChangeAspect="1"/>
           </p:cNvPicPr>
           <p:nvPr/>
         </p:nvPicPr>
         <p:blipFill>
-          <a:blip r:embed="rId2"/>
+          <a:blip r:embed="rId3"/>
           <a:stretch>
             <a:fillRect/>
           </a:stretch>
         </p:blipFill>
         <p:spPr>
           <a:xfrm>
-            <a:off x="9811512" y="3319272"/>
-            <a:ext cx="1408176" cy="2916936"/>
+            <a:off x="10040112" y="3364992"/>
+            <a:ext cx="1362456" cy="2825496"/>
           </a:xfrm>
           <a:prstGeom prst="rect">
             <a:avLst/>
           </a:prstGeom>
         </p:spPr>
       </p:pic>
-      <p:sp>
-        <p:nvSpPr>
-          <p:cNvPr id="19" name="Sparkle"/>
-          <p:cNvSpPr/>
-          <p:nvPr/>
-        </p:nvSpPr>
-        <p:spPr>
-          <a:xfrm>
-            <a:off x="6172200" y="914400"/>
-            <a:ext cx="329184" cy="329184"/>
-          </a:xfrm>
-          <a:prstGeom prst="star4">
-            <a:avLst/>
-          </a:prstGeom>
-          <a:solidFill>
-            <a:srgbClr val="F2C14E"/>
-          </a:solidFill>
-          <a:ln w="12700">
-            <a:solidFill>
-              <a:srgbClr val="F2C14E"/>
-            </a:solidFill>
-            <a:prstDash val="solid"/>
-          </a:ln>
-        </p:spPr>
-      </p:sp>
       <p:sp>
         <p:nvSpPr>
           <p:cNvPr id="20" name="Sparkle"/>
@@ -2903,18 +2921,18 @@
         </p:nvSpPr>
         <p:spPr>
           <a:xfrm>
-            <a:off x="11475720" y="777240"/>
-            <a:ext cx="219456" cy="219456"/>
+            <a:off x="6537960" y="868680"/>
+            <a:ext cx="329184" cy="329184"/>
           </a:xfrm>
           <a:prstGeom prst="star4">
             <a:avLst/>
           </a:prstGeom>
           <a:solidFill>
-            <a:srgbClr val="FFBDC5"/>
+            <a:srgbClr val="F2C14E"/>
           </a:solidFill>
           <a:ln w="12700">
             <a:solidFill>
-              <a:srgbClr val="FFBDC5"/>
+              <a:srgbClr val="F2C14E"/>
             </a:solidFill>
             <a:prstDash val="solid"/>
           </a:ln>
@@ -2928,18 +2946,18 @@
         </p:nvSpPr>
         <p:spPr>
           <a:xfrm>
-            <a:off x="6720840" y="5120640"/>
-            <a:ext cx="201168" cy="201168"/>
+            <a:off x="11521440" y="777240"/>
+            <a:ext cx="219456" cy="219456"/>
           </a:xfrm>
           <a:prstGeom prst="star4">
             <a:avLst/>
           </a:prstGeom>
           <a:solidFill>
-            <a:srgbClr val="C69FD5"/>
+            <a:srgbClr val="FFFFFF"/>
           </a:solidFill>
           <a:ln w="12700">
             <a:solidFill>
-              <a:srgbClr val="C69FD5"/>
+              <a:srgbClr val="FFFFFF"/>
             </a:solidFill>
             <a:prstDash val="solid"/>
           </a:ln>
@@ -11529,7 +11547,7 @@
         <p:spPr>
           <a:xfrm>
             <a:off x="548640" y="1463040"/>
-            <a:ext cx="5486400" cy="4572000"/>
+            <a:ext cx="4983480" cy="4572000"/>
           </a:xfrm>
           <a:prstGeom prst="roundRect">
             <a:avLst>
@@ -11587,7 +11605,7 @@
         <p:spPr>
           <a:xfrm>
             <a:off x="1325880" y="1719072"/>
-            <a:ext cx="4480560" cy="411480"/>
+            <a:ext cx="4023360" cy="411480"/>
           </a:xfrm>
           <a:prstGeom prst="rect">
             <a:avLst/>
@@ -11623,7 +11641,7 @@
         <p:spPr>
           <a:xfrm>
             <a:off x="822960" y="2377440"/>
-            <a:ext cx="1234440" cy="347472"/>
+            <a:ext cx="1143000" cy="347472"/>
           </a:xfrm>
           <a:prstGeom prst="roundRect">
             <a:avLst>
@@ -11669,8 +11687,8 @@
         </p:nvSpPr>
         <p:spPr>
           <a:xfrm>
-            <a:off x="2240280" y="2377440"/>
-            <a:ext cx="3611880" cy="347472"/>
+            <a:off x="2103120" y="2377440"/>
+            <a:ext cx="3291840" cy="347472"/>
           </a:xfrm>
           <a:prstGeom prst="rect">
             <a:avLst/>
@@ -11706,7 +11724,7 @@
         <p:spPr>
           <a:xfrm>
             <a:off x="822960" y="3063240"/>
-            <a:ext cx="1234440" cy="347472"/>
+            <a:ext cx="1143000" cy="347472"/>
           </a:xfrm>
           <a:prstGeom prst="roundRect">
             <a:avLst>
@@ -11752,8 +11770,8 @@
         </p:nvSpPr>
         <p:spPr>
           <a:xfrm>
-            <a:off x="2240280" y="3063240"/>
-            <a:ext cx="3611880" cy="347472"/>
+            <a:off x="2103120" y="3063240"/>
+            <a:ext cx="3291840" cy="347472"/>
           </a:xfrm>
           <a:prstGeom prst="rect">
             <a:avLst/>
@@ -11774,7 +11792,7 @@
                   <a:srgbClr val="1B1A24"/>
                 </a:solidFill>
               </a:rPr>
-              <a:t>2 public + 2 private across 2 AZs</a:t>
+              <a:t>2 public + 2 private, 2 AZs</a:t>
             </a:r>
             <a:endParaRPr lang="en-US" sz="1400" dirty="0"/>
           </a:p>
@@ -11789,7 +11807,7 @@
         <p:spPr>
           <a:xfrm>
             <a:off x="822960" y="3749040"/>
-            <a:ext cx="1234440" cy="347472"/>
+            <a:ext cx="1143000" cy="347472"/>
           </a:xfrm>
           <a:prstGeom prst="roundRect">
             <a:avLst>
@@ -11835,8 +11853,8 @@
         </p:nvSpPr>
         <p:spPr>
           <a:xfrm>
-            <a:off x="2240280" y="3749040"/>
-            <a:ext cx="3611880" cy="347472"/>
+            <a:off x="2103120" y="3749040"/>
+            <a:ext cx="3291840" cy="347472"/>
           </a:xfrm>
           <a:prstGeom prst="rect">
             <a:avLst/>
@@ -11857,7 +11875,7 @@
                   <a:srgbClr val="1B1A24"/>
                 </a:solidFill>
               </a:rPr>
-              <a:t>internet gateway, NAT gateway, route tables</a:t>
+              <a:t>internet gateway, NAT, route tables</a:t>
             </a:r>
             <a:endParaRPr lang="en-US" sz="1400" dirty="0"/>
           </a:p>
@@ -11872,7 +11890,7 @@
         <p:spPr>
           <a:xfrm>
             <a:off x="822960" y="4434840"/>
-            <a:ext cx="1234440" cy="347472"/>
+            <a:ext cx="1143000" cy="347472"/>
           </a:xfrm>
           <a:prstGeom prst="roundRect">
             <a:avLst>
@@ -11918,8 +11936,8 @@
         </p:nvSpPr>
         <p:spPr>
           <a:xfrm>
-            <a:off x="2240280" y="4434840"/>
-            <a:ext cx="3611880" cy="347472"/>
+            <a:off x="2103120" y="4434840"/>
+            <a:ext cx="3291840" cy="347472"/>
           </a:xfrm>
           <a:prstGeom prst="rect">
             <a:avLst/>
@@ -11940,7 +11958,7 @@
                   <a:srgbClr val="1B1A24"/>
                 </a:solidFill>
               </a:rPr>
-              <a:t>cluster, IAM roles, node group (switchable)</a:t>
+              <a:t>cluster, IAM, node group (switch)</a:t>
             </a:r>
             <a:endParaRPr lang="en-US" sz="1400" dirty="0"/>
           </a:p>
@@ -11955,7 +11973,7 @@
         <p:spPr>
           <a:xfrm>
             <a:off x="822960" y="5120640"/>
-            <a:ext cx="1234440" cy="347472"/>
+            <a:ext cx="1143000" cy="347472"/>
           </a:xfrm>
           <a:prstGeom prst="roundRect">
             <a:avLst>
@@ -12001,8 +12019,8 @@
         </p:nvSpPr>
         <p:spPr>
           <a:xfrm>
-            <a:off x="2240280" y="5120640"/>
-            <a:ext cx="3611880" cy="347472"/>
+            <a:off x="2103120" y="5120640"/>
+            <a:ext cx="3291840" cy="347472"/>
           </a:xfrm>
           <a:prstGeom prst="rect">
             <a:avLst/>
@@ -12023,7 +12041,7 @@
                   <a:srgbClr val="1B1A24"/>
                 </a:solidFill>
               </a:rPr>
-              <a:t>3 node local cluster, ports 80/443 mapped</a:t>
+              <a:t>3 node cluster, ports 80/443</a:t>
             </a:r>
             <a:endParaRPr lang="en-US" sz="1400" dirty="0"/>
           </a:p>
@@ -12031,14 +12049,72 @@
       </p:sp>
       <p:sp>
         <p:nvSpPr>
-          <p:cNvPr id="17" name="Text 14"/>
-          <p:cNvSpPr txBox="1"/>
-          <p:nvPr/>
-        </p:nvSpPr>
-        <p:spPr>
-          <a:xfrm>
-            <a:off x="6583680" y="1463040"/>
-            <a:ext cx="2103120" cy="1005840"/>
+          <p:cNvPr id="17" name="Sticker frame"/>
+          <p:cNvSpPr/>
+          <p:nvPr/>
+        </p:nvSpPr>
+        <p:spPr>
+          <a:xfrm>
+            <a:off x="5852160" y="1463040"/>
+            <a:ext cx="2788920" cy="2331720"/>
+          </a:xfrm>
+          <a:prstGeom prst="roundRect">
+            <a:avLst>
+              <a:gd name="adj" fmla="val 7059"/>
+            </a:avLst>
+          </a:prstGeom>
+          <a:solidFill>
+            <a:srgbClr val="FFFFFF"/>
+          </a:solidFill>
+          <a:ln w="12700">
+            <a:solidFill>
+              <a:srgbClr val="FFFFFF"/>
+            </a:solidFill>
+            <a:prstDash val="solid"/>
+          </a:ln>
+          <a:effectLst>
+            <a:outerShdw sx="100000" sy="100000" kx="0" ky="0" algn="bl" rotWithShape="0" blurRad="177800" dist="63500" dir="5400000">
+              <a:srgbClr val="1B1A24">
+                <a:alpha val="16000"/>
+              </a:srgbClr>
+            </a:outerShdw>
+          </a:effectLst>
+        </p:spPr>
+      </p:sp>
+      <p:pic>
+        <p:nvPicPr>
+          <p:cNvPr id="18" name="Image 1" descr="Illustration">    </p:cNvPr>
+          <p:cNvPicPr>
+            <a:picLocks noChangeAspect="1"/>
+          </p:cNvPicPr>
+          <p:nvPr/>
+        </p:nvPicPr>
+        <p:blipFill>
+          <a:blip r:embed="rId2"/>
+          <a:stretch>
+            <a:fillRect/>
+          </a:stretch>
+        </p:blipFill>
+        <p:spPr>
+          <a:xfrm>
+            <a:off x="5943600" y="1554480"/>
+            <a:ext cx="2606040" cy="2148840"/>
+          </a:xfrm>
+          <a:prstGeom prst="rect">
+            <a:avLst/>
+          </a:prstGeom>
+        </p:spPr>
+      </p:pic>
+      <p:sp>
+        <p:nvSpPr>
+          <p:cNvPr id="19" name="Text 15"/>
+          <p:cNvSpPr txBox="1"/>
+          <p:nvPr/>
+        </p:nvSpPr>
+        <p:spPr>
+          <a:xfrm>
+            <a:off x="5852160" y="3886200"/>
+            <a:ext cx="2788920" cy="320040"/>
           </a:xfrm>
           <a:prstGeom prst="rect">
             <a:avLst/>
@@ -12050,34 +12126,34 @@
           <a:bodyPr wrap="square" lIns="0" tIns="0" rIns="0" bIns="0" rtlCol="0" anchor="ctr"/>
           <a:lstStyle/>
           <a:p>
-            <a:pPr indent="0" marL="0">
-              <a:buNone/>
-            </a:pPr>
-            <a:r>
-              <a:rPr lang="en-US" sz="6000" dirty="0">
-                <a:solidFill>
-                  <a:srgbClr val="2E7A8C"/>
+            <a:pPr algn="ctr" indent="0" marL="0">
+              <a:buNone/>
+            </a:pPr>
+            <a:r>
+              <a:rPr lang="en-US" sz="1200" dirty="0">
+                <a:solidFill>
+                  <a:srgbClr val="6B6475"/>
                 </a:solidFill>
                 <a:latin typeface="Roboto Mono" pitchFamily="34" charset="0"/>
                 <a:ea typeface="Roboto Mono" pitchFamily="34" charset="-122"/>
                 <a:cs typeface="Roboto Mono" pitchFamily="34" charset="-120"/>
               </a:rPr>
-              <a:t>15</a:t>
-            </a:r>
-            <a:endParaRPr lang="en-US" sz="6000" dirty="0"/>
-          </a:p>
-        </p:txBody>
-      </p:sp>
-      <p:sp>
-        <p:nvSpPr>
-          <p:cNvPr id="18" name="Text 15"/>
-          <p:cNvSpPr txBox="1"/>
-          <p:nvPr/>
-        </p:nvSpPr>
-        <p:spPr>
-          <a:xfrm>
-            <a:off x="8183880" y="1463040"/>
-            <a:ext cx="3474720" cy="1005840"/>
+              <a:t>reviewing terraform plan</a:t>
+            </a:r>
+            <a:endParaRPr lang="en-US" sz="1200" dirty="0"/>
+          </a:p>
+        </p:txBody>
+      </p:sp>
+      <p:sp>
+        <p:nvSpPr>
+          <p:cNvPr id="20" name="Text 16"/>
+          <p:cNvSpPr txBox="1"/>
+          <p:nvPr/>
+        </p:nvSpPr>
+        <p:spPr>
+          <a:xfrm>
+            <a:off x="8961120" y="1463040"/>
+            <a:ext cx="1097280" cy="777240"/>
           </a:xfrm>
           <a:prstGeom prst="rect">
             <a:avLst/>
@@ -12093,66 +12169,30 @@
               <a:buNone/>
             </a:pPr>
             <a:r>
-              <a:rPr lang="en-US" sz="1600" dirty="0">
-                <a:solidFill>
-                  <a:srgbClr val="1B1A24"/>
-                </a:solidFill>
-              </a:rPr>
-              <a:t>resources applied</a:t>
-            </a:r>
-            <a:endParaRPr lang="en-US" sz="1600" dirty="0"/>
-          </a:p>
-        </p:txBody>
-      </p:sp>
-      <p:sp>
-        <p:nvSpPr>
-          <p:cNvPr id="19" name="Text 16"/>
-          <p:cNvSpPr txBox="1"/>
-          <p:nvPr/>
-        </p:nvSpPr>
-        <p:spPr>
-          <a:xfrm>
-            <a:off x="6583680" y="2788920"/>
-            <a:ext cx="2103120" cy="1005840"/>
-          </a:xfrm>
-          <a:prstGeom prst="rect">
-            <a:avLst/>
-          </a:prstGeom>
-          <a:noFill/>
-          <a:ln/>
-        </p:spPr>
-        <p:txBody>
-          <a:bodyPr wrap="square" lIns="0" tIns="0" rIns="0" bIns="0" rtlCol="0" anchor="ctr"/>
-          <a:lstStyle/>
-          <a:p>
-            <a:pPr indent="0" marL="0">
-              <a:buNone/>
-            </a:pPr>
-            <a:r>
-              <a:rPr lang="en-US" sz="6000" dirty="0">
-                <a:solidFill>
-                  <a:srgbClr val="C69FD5"/>
+              <a:rPr lang="en-US" sz="4400" b="1" dirty="0">
+                <a:solidFill>
+                  <a:srgbClr val="2E7A8C"/>
                 </a:solidFill>
                 <a:latin typeface="Roboto Mono" pitchFamily="34" charset="0"/>
                 <a:ea typeface="Roboto Mono" pitchFamily="34" charset="-122"/>
                 <a:cs typeface="Roboto Mono" pitchFamily="34" charset="-120"/>
               </a:rPr>
-              <a:t>23</a:t>
-            </a:r>
-            <a:endParaRPr lang="en-US" sz="6000" dirty="0"/>
-          </a:p>
-        </p:txBody>
-      </p:sp>
-      <p:sp>
-        <p:nvSpPr>
-          <p:cNvPr id="20" name="Text 17"/>
-          <p:cNvSpPr txBox="1"/>
-          <p:nvPr/>
-        </p:nvSpPr>
-        <p:spPr>
-          <a:xfrm>
-            <a:off x="8183880" y="2788920"/>
-            <a:ext cx="3474720" cy="1005840"/>
+              <a:t>15</a:t>
+            </a:r>
+            <a:endParaRPr lang="en-US" sz="4400" dirty="0"/>
+          </a:p>
+        </p:txBody>
+      </p:sp>
+      <p:sp>
+        <p:nvSpPr>
+          <p:cNvPr id="21" name="Text 17"/>
+          <p:cNvSpPr txBox="1"/>
+          <p:nvPr/>
+        </p:nvSpPr>
+        <p:spPr>
+          <a:xfrm>
+            <a:off x="10058400" y="1463040"/>
+            <a:ext cx="1645920" cy="777240"/>
           </a:xfrm>
           <a:prstGeom prst="rect">
             <a:avLst/>
@@ -12168,27 +12208,27 @@
               <a:buNone/>
             </a:pPr>
             <a:r>
-              <a:rPr lang="en-US" sz="1600" dirty="0">
+              <a:rPr lang="en-US" sz="1400" dirty="0">
                 <a:solidFill>
                   <a:srgbClr val="1B1A24"/>
                 </a:solidFill>
               </a:rPr>
-              <a:t>with EKS switched on</a:t>
-            </a:r>
-            <a:endParaRPr lang="en-US" sz="1600" dirty="0"/>
-          </a:p>
-        </p:txBody>
-      </p:sp>
-      <p:sp>
-        <p:nvSpPr>
-          <p:cNvPr id="21" name="Text 18"/>
-          <p:cNvSpPr txBox="1"/>
-          <p:nvPr/>
-        </p:nvSpPr>
-        <p:spPr>
-          <a:xfrm>
-            <a:off x="6583680" y="4114800"/>
-            <a:ext cx="2103120" cy="1005840"/>
+              <a:t>resources applied</a:t>
+            </a:r>
+            <a:endParaRPr lang="en-US" sz="1400" dirty="0"/>
+          </a:p>
+        </p:txBody>
+      </p:sp>
+      <p:sp>
+        <p:nvSpPr>
+          <p:cNvPr id="22" name="Text 18"/>
+          <p:cNvSpPr txBox="1"/>
+          <p:nvPr/>
+        </p:nvSpPr>
+        <p:spPr>
+          <a:xfrm>
+            <a:off x="8961120" y="2359152"/>
+            <a:ext cx="1097280" cy="777240"/>
           </a:xfrm>
           <a:prstGeom prst="rect">
             <a:avLst/>
@@ -12204,30 +12244,105 @@
               <a:buNone/>
             </a:pPr>
             <a:r>
-              <a:rPr lang="en-US" sz="6000" dirty="0">
-                <a:solidFill>
-                  <a:srgbClr val="A13C4C"/>
+              <a:rPr lang="en-US" sz="4400" b="1" dirty="0">
+                <a:solidFill>
+                  <a:srgbClr val="C69FD5"/>
                 </a:solidFill>
                 <a:latin typeface="Roboto Mono" pitchFamily="34" charset="0"/>
                 <a:ea typeface="Roboto Mono" pitchFamily="34" charset="-122"/>
                 <a:cs typeface="Roboto Mono" pitchFamily="34" charset="-120"/>
               </a:rPr>
+              <a:t>23</a:t>
+            </a:r>
+            <a:endParaRPr lang="en-US" sz="4400" dirty="0"/>
+          </a:p>
+        </p:txBody>
+      </p:sp>
+      <p:sp>
+        <p:nvSpPr>
+          <p:cNvPr id="23" name="Text 19"/>
+          <p:cNvSpPr txBox="1"/>
+          <p:nvPr/>
+        </p:nvSpPr>
+        <p:spPr>
+          <a:xfrm>
+            <a:off x="10058400" y="2359152"/>
+            <a:ext cx="1645920" cy="777240"/>
+          </a:xfrm>
+          <a:prstGeom prst="rect">
+            <a:avLst/>
+          </a:prstGeom>
+          <a:noFill/>
+          <a:ln/>
+        </p:spPr>
+        <p:txBody>
+          <a:bodyPr wrap="square" lIns="0" tIns="0" rIns="0" bIns="0" rtlCol="0" anchor="ctr"/>
+          <a:lstStyle/>
+          <a:p>
+            <a:pPr indent="0" marL="0">
+              <a:buNone/>
+            </a:pPr>
+            <a:r>
+              <a:rPr lang="en-US" sz="1400" dirty="0">
+                <a:solidFill>
+                  <a:srgbClr val="1B1A24"/>
+                </a:solidFill>
+              </a:rPr>
+              <a:t>with EKS switched on</a:t>
+            </a:r>
+            <a:endParaRPr lang="en-US" sz="1400" dirty="0"/>
+          </a:p>
+        </p:txBody>
+      </p:sp>
+      <p:sp>
+        <p:nvSpPr>
+          <p:cNvPr id="24" name="Text 20"/>
+          <p:cNvSpPr txBox="1"/>
+          <p:nvPr/>
+        </p:nvSpPr>
+        <p:spPr>
+          <a:xfrm>
+            <a:off x="8961120" y="3255264"/>
+            <a:ext cx="1097280" cy="777240"/>
+          </a:xfrm>
+          <a:prstGeom prst="rect">
+            <a:avLst/>
+          </a:prstGeom>
+          <a:noFill/>
+          <a:ln/>
+        </p:spPr>
+        <p:txBody>
+          <a:bodyPr wrap="square" lIns="0" tIns="0" rIns="0" bIns="0" rtlCol="0" anchor="ctr"/>
+          <a:lstStyle/>
+          <a:p>
+            <a:pPr indent="0" marL="0">
+              <a:buNone/>
+            </a:pPr>
+            <a:r>
+              <a:rPr lang="en-US" sz="4400" b="1" dirty="0">
+                <a:solidFill>
+                  <a:srgbClr val="A13C4C"/>
+                </a:solidFill>
+                <a:latin typeface="Roboto Mono" pitchFamily="34" charset="0"/>
+                <a:ea typeface="Roboto Mono" pitchFamily="34" charset="-122"/>
+                <a:cs typeface="Roboto Mono" pitchFamily="34" charset="-120"/>
+              </a:rPr>
               <a:t>2</a:t>
             </a:r>
-            <a:endParaRPr lang="en-US" sz="6000" dirty="0"/>
-          </a:p>
-        </p:txBody>
-      </p:sp>
-      <p:sp>
-        <p:nvSpPr>
-          <p:cNvPr id="22" name="Text 19"/>
-          <p:cNvSpPr txBox="1"/>
-          <p:nvPr/>
-        </p:nvSpPr>
-        <p:spPr>
-          <a:xfrm>
-            <a:off x="8183880" y="4114800"/>
-            <a:ext cx="3474720" cy="1005840"/>
+            <a:endParaRPr lang="en-US" sz="4400" dirty="0"/>
+          </a:p>
+        </p:txBody>
+      </p:sp>
+      <p:sp>
+        <p:nvSpPr>
+          <p:cNvPr id="25" name="Text 21"/>
+          <p:cNvSpPr txBox="1"/>
+          <p:nvPr/>
+        </p:nvSpPr>
+        <p:spPr>
+          <a:xfrm>
+            <a:off x="10058400" y="3255264"/>
+            <a:ext cx="1645920" cy="777240"/>
           </a:xfrm>
           <a:prstGeom prst="rect">
             <a:avLst/>
@@ -12243,27 +12358,27 @@
               <a:buNone/>
             </a:pPr>
             <a:r>
-              <a:rPr lang="en-US" sz="1600" dirty="0">
+              <a:rPr lang="en-US" sz="1400" dirty="0">
                 <a:solidFill>
                   <a:srgbClr val="1B1A24"/>
                 </a:solidFill>
               </a:rPr>
-              <a:t>availability zones, one NAT gateway</a:t>
-            </a:r>
-            <a:endParaRPr lang="en-US" sz="1600" dirty="0"/>
-          </a:p>
-        </p:txBody>
-      </p:sp>
-      <p:sp>
-        <p:nvSpPr>
-          <p:cNvPr id="23" name="Text 20"/>
-          <p:cNvSpPr txBox="1"/>
-          <p:nvPr/>
-        </p:nvSpPr>
-        <p:spPr>
-          <a:xfrm>
-            <a:off x="6583680" y="5532120"/>
-            <a:ext cx="1600200" cy="347472"/>
+              <a:t>AZs, one NAT gateway</a:t>
+            </a:r>
+            <a:endParaRPr lang="en-US" sz="1400" dirty="0"/>
+          </a:p>
+        </p:txBody>
+      </p:sp>
+      <p:sp>
+        <p:nvSpPr>
+          <p:cNvPr id="26" name="Text 22"/>
+          <p:cNvSpPr txBox="1"/>
+          <p:nvPr/>
+        </p:nvSpPr>
+        <p:spPr>
+          <a:xfrm>
+            <a:off x="5852160" y="4754880"/>
+            <a:ext cx="1828800" cy="347472"/>
           </a:xfrm>
           <a:prstGeom prst="roundRect">
             <a:avLst>
@@ -12303,14 +12418,14 @@
       </p:sp>
       <p:sp>
         <p:nvSpPr>
-          <p:cNvPr id="24" name="Text 21"/>
-          <p:cNvSpPr txBox="1"/>
-          <p:nvPr/>
-        </p:nvSpPr>
-        <p:spPr>
-          <a:xfrm>
-            <a:off x="8321040" y="5532120"/>
-            <a:ext cx="1600200" cy="347472"/>
+          <p:cNvPr id="27" name="Text 23"/>
+          <p:cNvSpPr txBox="1"/>
+          <p:nvPr/>
+        </p:nvSpPr>
+        <p:spPr>
+          <a:xfrm>
+            <a:off x="7818120" y="4754880"/>
+            <a:ext cx="1828800" cy="347472"/>
           </a:xfrm>
           <a:prstGeom prst="roundRect">
             <a:avLst>
@@ -12350,14 +12465,14 @@
       </p:sp>
       <p:sp>
         <p:nvSpPr>
-          <p:cNvPr id="25" name="Text 22"/>
-          <p:cNvSpPr txBox="1"/>
-          <p:nvPr/>
-        </p:nvSpPr>
-        <p:spPr>
-          <a:xfrm>
-            <a:off x="10058400" y="5532120"/>
-            <a:ext cx="1600200" cy="347472"/>
+          <p:cNvPr id="28" name="Text 24"/>
+          <p:cNvSpPr txBox="1"/>
+          <p:nvPr/>
+        </p:nvSpPr>
+        <p:spPr>
+          <a:xfrm>
+            <a:off x="9784080" y="4754880"/>
+            <a:ext cx="1828800" cy="347472"/>
           </a:xfrm>
           <a:prstGeom prst="roundRect">
             <a:avLst>
@@ -12392,6 +12507,42 @@
               <a:t>terraform destroy</a:t>
             </a:r>
             <a:endParaRPr lang="en-US" sz="1200" dirty="0"/>
+          </a:p>
+        </p:txBody>
+      </p:sp>
+      <p:sp>
+        <p:nvSpPr>
+          <p:cNvPr id="29" name="Text 25"/>
+          <p:cNvSpPr txBox="1"/>
+          <p:nvPr/>
+        </p:nvSpPr>
+        <p:spPr>
+          <a:xfrm>
+            <a:off x="5852160" y="5303520"/>
+            <a:ext cx="5806440" cy="457200"/>
+          </a:xfrm>
+          <a:prstGeom prst="rect">
+            <a:avLst/>
+          </a:prstGeom>
+          <a:noFill/>
+          <a:ln/>
+        </p:spPr>
+        <p:txBody>
+          <a:bodyPr wrap="square" lIns="0" tIns="0" rIns="0" bIns="0" rtlCol="0" anchor="ctr"/>
+          <a:lstStyle/>
+          <a:p>
+            <a:pPr indent="0" marL="0">
+              <a:buNone/>
+            </a:pPr>
+            <a:r>
+              <a:rPr lang="en-US" sz="1400" dirty="0">
+                <a:solidFill>
+                  <a:srgbClr val="6B6475"/>
+                </a:solidFill>
+              </a:rPr>
+              <a:t>Runs against LocalStack by default; one variable switches it to real AWS.</a:t>
+            </a:r>
+            <a:endParaRPr lang="en-US" sz="1400" dirty="0"/>
           </a:p>
         </p:txBody>
       </p:sp>
@@ -13614,326 +13765,26 @@
       </p:sp>
       <p:sp>
         <p:nvSpPr>
-          <p:cNvPr id="4" name="Text 2"/>
-          <p:cNvSpPr txBox="1"/>
-          <p:nvPr/>
-        </p:nvSpPr>
-        <p:spPr>
-          <a:xfrm>
-            <a:off x="548640" y="1508760"/>
-            <a:ext cx="2377440" cy="685800"/>
-          </a:xfrm>
-          <a:prstGeom prst="rect">
-            <a:avLst/>
-          </a:prstGeom>
-          <a:noFill/>
-          <a:ln/>
-        </p:spPr>
-        <p:txBody>
-          <a:bodyPr wrap="square" lIns="0" tIns="0" rIns="0" bIns="0" rtlCol="0" anchor="ctr"/>
-          <a:lstStyle/>
-          <a:p>
-            <a:pPr indent="0" marL="0">
-              <a:buNone/>
-            </a:pPr>
-            <a:r>
-              <a:rPr lang="en-US" sz="4000" dirty="0">
-                <a:solidFill>
-                  <a:srgbClr val="4C9DB0"/>
-                </a:solidFill>
-                <a:latin typeface="Roboto Mono" pitchFamily="34" charset="0"/>
-                <a:ea typeface="Roboto Mono" pitchFamily="34" charset="-122"/>
-                <a:cs typeface="Roboto Mono" pitchFamily="34" charset="-120"/>
-              </a:rPr>
-              <a:t>13</a:t>
-            </a:r>
-            <a:endParaRPr lang="en-US" sz="4000" dirty="0"/>
-          </a:p>
-        </p:txBody>
-      </p:sp>
-      <p:sp>
-        <p:nvSpPr>
-          <p:cNvPr id="5" name="Text 3"/>
-          <p:cNvSpPr txBox="1"/>
-          <p:nvPr/>
-        </p:nvSpPr>
-        <p:spPr>
-          <a:xfrm>
-            <a:off x="548640" y="2167128"/>
-            <a:ext cx="3108960" cy="320040"/>
-          </a:xfrm>
-          <a:prstGeom prst="rect">
-            <a:avLst/>
-          </a:prstGeom>
-          <a:noFill/>
-          <a:ln/>
-        </p:spPr>
-        <p:txBody>
-          <a:bodyPr wrap="square" lIns="0" tIns="0" rIns="0" bIns="0" rtlCol="0" anchor="ctr"/>
-          <a:lstStyle/>
-          <a:p>
-            <a:pPr indent="0" marL="0">
-              <a:buNone/>
-            </a:pPr>
-            <a:r>
-              <a:rPr lang="en-US" sz="1300" dirty="0">
-                <a:solidFill>
-                  <a:srgbClr val="AEB8C8"/>
-                </a:solidFill>
-              </a:rPr>
-              <a:t>Grafana panels</a:t>
-            </a:r>
-            <a:endParaRPr lang="en-US" sz="1300" dirty="0"/>
-          </a:p>
-        </p:txBody>
-      </p:sp>
-      <p:sp>
-        <p:nvSpPr>
-          <p:cNvPr id="6" name="Text 4"/>
-          <p:cNvSpPr txBox="1"/>
-          <p:nvPr/>
-        </p:nvSpPr>
-        <p:spPr>
-          <a:xfrm>
-            <a:off x="548640" y="2624328"/>
-            <a:ext cx="2377440" cy="685800"/>
-          </a:xfrm>
-          <a:prstGeom prst="rect">
-            <a:avLst/>
-          </a:prstGeom>
-          <a:noFill/>
-          <a:ln/>
-        </p:spPr>
-        <p:txBody>
-          <a:bodyPr wrap="square" lIns="0" tIns="0" rIns="0" bIns="0" rtlCol="0" anchor="ctr"/>
-          <a:lstStyle/>
-          <a:p>
-            <a:pPr indent="0" marL="0">
-              <a:buNone/>
-            </a:pPr>
-            <a:r>
-              <a:rPr lang="en-US" sz="4000" dirty="0">
-                <a:solidFill>
-                  <a:srgbClr val="FFBDC5"/>
-                </a:solidFill>
-                <a:latin typeface="Roboto Mono" pitchFamily="34" charset="0"/>
-                <a:ea typeface="Roboto Mono" pitchFamily="34" charset="-122"/>
-                <a:cs typeface="Roboto Mono" pitchFamily="34" charset="-120"/>
-              </a:rPr>
-              <a:t>~40</a:t>
-            </a:r>
-            <a:endParaRPr lang="en-US" sz="4000" dirty="0"/>
-          </a:p>
-        </p:txBody>
-      </p:sp>
-      <p:sp>
-        <p:nvSpPr>
-          <p:cNvPr id="7" name="Text 5"/>
-          <p:cNvSpPr txBox="1"/>
-          <p:nvPr/>
-        </p:nvSpPr>
-        <p:spPr>
-          <a:xfrm>
-            <a:off x="548640" y="3282696"/>
-            <a:ext cx="3108960" cy="320040"/>
-          </a:xfrm>
-          <a:prstGeom prst="rect">
-            <a:avLst/>
-          </a:prstGeom>
-          <a:noFill/>
-          <a:ln/>
-        </p:spPr>
-        <p:txBody>
-          <a:bodyPr wrap="square" lIns="0" tIns="0" rIns="0" bIns="0" rtlCol="0" anchor="ctr"/>
-          <a:lstStyle/>
-          <a:p>
-            <a:pPr indent="0" marL="0">
-              <a:buNone/>
-            </a:pPr>
-            <a:r>
-              <a:rPr lang="en-US" sz="1300" dirty="0">
-                <a:solidFill>
-                  <a:srgbClr val="AEB8C8"/>
-                </a:solidFill>
-              </a:rPr>
-              <a:t>requests / sec under load</a:t>
-            </a:r>
-            <a:endParaRPr lang="en-US" sz="1300" dirty="0"/>
-          </a:p>
-        </p:txBody>
-      </p:sp>
-      <p:sp>
-        <p:nvSpPr>
-          <p:cNvPr id="8" name="Text 6"/>
-          <p:cNvSpPr txBox="1"/>
-          <p:nvPr/>
-        </p:nvSpPr>
-        <p:spPr>
-          <a:xfrm>
-            <a:off x="548640" y="3739896"/>
-            <a:ext cx="2377440" cy="685800"/>
-          </a:xfrm>
-          <a:prstGeom prst="rect">
-            <a:avLst/>
-          </a:prstGeom>
-          <a:noFill/>
-          <a:ln/>
-        </p:spPr>
-        <p:txBody>
-          <a:bodyPr wrap="square" lIns="0" tIns="0" rIns="0" bIns="0" rtlCol="0" anchor="ctr"/>
-          <a:lstStyle/>
-          <a:p>
-            <a:pPr indent="0" marL="0">
-              <a:buNone/>
-            </a:pPr>
-            <a:r>
-              <a:rPr lang="en-US" sz="4000" dirty="0">
-                <a:solidFill>
-                  <a:srgbClr val="4C9DB0"/>
-                </a:solidFill>
-                <a:latin typeface="Roboto Mono" pitchFamily="34" charset="0"/>
-                <a:ea typeface="Roboto Mono" pitchFamily="34" charset="-122"/>
-                <a:cs typeface="Roboto Mono" pitchFamily="34" charset="-120"/>
-              </a:rPr>
-              <a:t>~10 ms</a:t>
-            </a:r>
-            <a:endParaRPr lang="en-US" sz="4000" dirty="0"/>
-          </a:p>
-        </p:txBody>
-      </p:sp>
-      <p:sp>
-        <p:nvSpPr>
-          <p:cNvPr id="9" name="Text 7"/>
-          <p:cNvSpPr txBox="1"/>
-          <p:nvPr/>
-        </p:nvSpPr>
-        <p:spPr>
-          <a:xfrm>
-            <a:off x="548640" y="4398264"/>
-            <a:ext cx="3108960" cy="320040"/>
-          </a:xfrm>
-          <a:prstGeom prst="rect">
-            <a:avLst/>
-          </a:prstGeom>
-          <a:noFill/>
-          <a:ln/>
-        </p:spPr>
-        <p:txBody>
-          <a:bodyPr wrap="square" lIns="0" tIns="0" rIns="0" bIns="0" rtlCol="0" anchor="ctr"/>
-          <a:lstStyle/>
-          <a:p>
-            <a:pPr indent="0" marL="0">
-              <a:buNone/>
-            </a:pPr>
-            <a:r>
-              <a:rPr lang="en-US" sz="1300" dirty="0">
-                <a:solidFill>
-                  <a:srgbClr val="AEB8C8"/>
-                </a:solidFill>
-              </a:rPr>
-              <a:t>p95 latency</a:t>
-            </a:r>
-            <a:endParaRPr lang="en-US" sz="1300" dirty="0"/>
-          </a:p>
-        </p:txBody>
-      </p:sp>
-      <p:sp>
-        <p:nvSpPr>
-          <p:cNvPr id="10" name="Text 8"/>
-          <p:cNvSpPr txBox="1"/>
-          <p:nvPr/>
-        </p:nvSpPr>
-        <p:spPr>
-          <a:xfrm>
-            <a:off x="548640" y="4855464"/>
-            <a:ext cx="2377440" cy="685800"/>
-          </a:xfrm>
-          <a:prstGeom prst="rect">
-            <a:avLst/>
-          </a:prstGeom>
-          <a:noFill/>
-          <a:ln/>
-        </p:spPr>
-        <p:txBody>
-          <a:bodyPr wrap="square" lIns="0" tIns="0" rIns="0" bIns="0" rtlCol="0" anchor="ctr"/>
-          <a:lstStyle/>
-          <a:p>
-            <a:pPr indent="0" marL="0">
-              <a:buNone/>
-            </a:pPr>
-            <a:r>
-              <a:rPr lang="en-US" sz="4000" dirty="0">
-                <a:solidFill>
-                  <a:srgbClr val="FFBDC5"/>
-                </a:solidFill>
-                <a:latin typeface="Roboto Mono" pitchFamily="34" charset="0"/>
-                <a:ea typeface="Roboto Mono" pitchFamily="34" charset="-122"/>
-                <a:cs typeface="Roboto Mono" pitchFamily="34" charset="-120"/>
-              </a:rPr>
-              <a:t>UP</a:t>
-            </a:r>
-            <a:endParaRPr lang="en-US" sz="4000" dirty="0"/>
-          </a:p>
-        </p:txBody>
-      </p:sp>
-      <p:sp>
-        <p:nvSpPr>
-          <p:cNvPr id="11" name="Text 9"/>
-          <p:cNvSpPr txBox="1"/>
-          <p:nvPr/>
-        </p:nvSpPr>
-        <p:spPr>
-          <a:xfrm>
-            <a:off x="548640" y="5513832"/>
-            <a:ext cx="3108960" cy="320040"/>
-          </a:xfrm>
-          <a:prstGeom prst="rect">
-            <a:avLst/>
-          </a:prstGeom>
-          <a:noFill/>
-          <a:ln/>
-        </p:spPr>
-        <p:txBody>
-          <a:bodyPr wrap="square" lIns="0" tIns="0" rIns="0" bIns="0" rtlCol="0" anchor="ctr"/>
-          <a:lstStyle/>
-          <a:p>
-            <a:pPr indent="0" marL="0">
-              <a:buNone/>
-            </a:pPr>
-            <a:r>
-              <a:rPr lang="en-US" sz="1300" dirty="0">
-                <a:solidFill>
-                  <a:srgbClr val="AEB8C8"/>
-                </a:solidFill>
-              </a:rPr>
-              <a:t>every scrape target</a:t>
-            </a:r>
-            <a:endParaRPr lang="en-US" sz="1300" dirty="0"/>
-          </a:p>
-        </p:txBody>
-      </p:sp>
-      <p:sp>
-        <p:nvSpPr>
-          <p:cNvPr id="12" name="Browser frame"/>
+          <p:cNvPr id="4" name="Sticker frame"/>
           <p:cNvSpPr/>
           <p:nvPr/>
         </p:nvSpPr>
         <p:spPr>
           <a:xfrm>
-            <a:off x="4087368" y="1453896"/>
-            <a:ext cx="7644384" cy="4626864"/>
+            <a:off x="548640" y="1417320"/>
+            <a:ext cx="2834640" cy="2834640"/>
           </a:xfrm>
           <a:prstGeom prst="roundRect">
             <a:avLst>
-              <a:gd name="adj" fmla="val 2767"/>
+              <a:gd name="adj" fmla="val 5806"/>
             </a:avLst>
           </a:prstGeom>
           <a:solidFill>
-            <a:srgbClr val="0F1622"/>
-          </a:solidFill>
-          <a:ln w="9525">
-            <a:solidFill>
-              <a:srgbClr val="0F1622"/>
+            <a:srgbClr val="FFFFFF"/>
+          </a:solidFill>
+          <a:ln w="12700">
+            <a:solidFill>
+              <a:srgbClr val="FFFFFF"/>
             </a:solidFill>
             <a:prstDash val="solid"/>
           </a:ln>
@@ -13946,84 +13797,9 @@
           </a:effectLst>
         </p:spPr>
       </p:sp>
-      <p:sp>
-        <p:nvSpPr>
-          <p:cNvPr id="13" name="Window dot"/>
-          <p:cNvSpPr/>
-          <p:nvPr/>
-        </p:nvSpPr>
-        <p:spPr>
-          <a:xfrm>
-            <a:off x="4233672" y="1563624"/>
-            <a:ext cx="109728" cy="109728"/>
-          </a:xfrm>
-          <a:prstGeom prst="ellipse">
-            <a:avLst/>
-          </a:prstGeom>
-          <a:solidFill>
-            <a:srgbClr val="FF5F57"/>
-          </a:solidFill>
-          <a:ln w="12700">
-            <a:solidFill>
-              <a:srgbClr val="FF5F57"/>
-            </a:solidFill>
-            <a:prstDash val="solid"/>
-          </a:ln>
-        </p:spPr>
-      </p:sp>
-      <p:sp>
-        <p:nvSpPr>
-          <p:cNvPr id="14" name="Window dot"/>
-          <p:cNvSpPr/>
-          <p:nvPr/>
-        </p:nvSpPr>
-        <p:spPr>
-          <a:xfrm>
-            <a:off x="4416552" y="1563624"/>
-            <a:ext cx="109728" cy="109728"/>
-          </a:xfrm>
-          <a:prstGeom prst="ellipse">
-            <a:avLst/>
-          </a:prstGeom>
-          <a:solidFill>
-            <a:srgbClr val="FEBC2E"/>
-          </a:solidFill>
-          <a:ln w="12700">
-            <a:solidFill>
-              <a:srgbClr val="FEBC2E"/>
-            </a:solidFill>
-            <a:prstDash val="solid"/>
-          </a:ln>
-        </p:spPr>
-      </p:sp>
-      <p:sp>
-        <p:nvSpPr>
-          <p:cNvPr id="15" name="Window dot"/>
-          <p:cNvSpPr/>
-          <p:nvPr/>
-        </p:nvSpPr>
-        <p:spPr>
-          <a:xfrm>
-            <a:off x="4599432" y="1563624"/>
-            <a:ext cx="109728" cy="109728"/>
-          </a:xfrm>
-          <a:prstGeom prst="ellipse">
-            <a:avLst/>
-          </a:prstGeom>
-          <a:solidFill>
-            <a:srgbClr val="28C840"/>
-          </a:solidFill>
-          <a:ln w="12700">
-            <a:solidFill>
-              <a:srgbClr val="28C840"/>
-            </a:solidFill>
-            <a:prstDash val="solid"/>
-          </a:ln>
-        </p:spPr>
-      </p:sp>
       <p:pic>
         <p:nvPicPr>
-          <p:cNvPr id="16" name="Image 0" descr="Screenshot of the running Fellow stack">    </p:cNvPr>
+          <p:cNvPr id="5" name="Image 0" descr="Illustration">    </p:cNvPr>
           <p:cNvPicPr>
             <a:picLocks noChangeAspect="1"/>
           </p:cNvPicPr>
@@ -14031,6 +13807,439 @@
         </p:nvPicPr>
         <p:blipFill>
           <a:blip r:embed="rId1"/>
+          <a:stretch>
+            <a:fillRect/>
+          </a:stretch>
+        </p:blipFill>
+        <p:spPr>
+          <a:xfrm>
+            <a:off x="640080" y="1508760"/>
+            <a:ext cx="2651760" cy="2651760"/>
+          </a:xfrm>
+          <a:prstGeom prst="rect">
+            <a:avLst/>
+          </a:prstGeom>
+        </p:spPr>
+      </p:pic>
+      <p:sp>
+        <p:nvSpPr>
+          <p:cNvPr id="6" name="Text 3"/>
+          <p:cNvSpPr txBox="1"/>
+          <p:nvPr/>
+        </p:nvSpPr>
+        <p:spPr>
+          <a:xfrm>
+            <a:off x="548640" y="4480560"/>
+            <a:ext cx="1554480" cy="457200"/>
+          </a:xfrm>
+          <a:prstGeom prst="rect">
+            <a:avLst/>
+          </a:prstGeom>
+          <a:noFill/>
+          <a:ln/>
+        </p:spPr>
+        <p:txBody>
+          <a:bodyPr wrap="square" lIns="0" tIns="0" rIns="0" bIns="0" rtlCol="0" anchor="ctr"/>
+          <a:lstStyle/>
+          <a:p>
+            <a:pPr indent="0" marL="0">
+              <a:buNone/>
+            </a:pPr>
+            <a:r>
+              <a:rPr lang="en-US" sz="2400" b="1" dirty="0">
+                <a:solidFill>
+                  <a:srgbClr val="4C9DB0"/>
+                </a:solidFill>
+                <a:latin typeface="Roboto Mono" pitchFamily="34" charset="0"/>
+                <a:ea typeface="Roboto Mono" pitchFamily="34" charset="-122"/>
+                <a:cs typeface="Roboto Mono" pitchFamily="34" charset="-120"/>
+              </a:rPr>
+              <a:t>13</a:t>
+            </a:r>
+            <a:endParaRPr lang="en-US" sz="2400" dirty="0"/>
+          </a:p>
+        </p:txBody>
+      </p:sp>
+      <p:sp>
+        <p:nvSpPr>
+          <p:cNvPr id="7" name="Text 4"/>
+          <p:cNvSpPr txBox="1"/>
+          <p:nvPr/>
+        </p:nvSpPr>
+        <p:spPr>
+          <a:xfrm>
+            <a:off x="548640" y="4937760"/>
+            <a:ext cx="1554480" cy="274320"/>
+          </a:xfrm>
+          <a:prstGeom prst="rect">
+            <a:avLst/>
+          </a:prstGeom>
+          <a:noFill/>
+          <a:ln/>
+        </p:spPr>
+        <p:txBody>
+          <a:bodyPr wrap="square" lIns="0" tIns="0" rIns="0" bIns="0" rtlCol="0" anchor="ctr"/>
+          <a:lstStyle/>
+          <a:p>
+            <a:pPr indent="0" marL="0">
+              <a:buNone/>
+            </a:pPr>
+            <a:r>
+              <a:rPr lang="en-US" sz="1100" dirty="0">
+                <a:solidFill>
+                  <a:srgbClr val="AEB8C8"/>
+                </a:solidFill>
+              </a:rPr>
+              <a:t>Grafana panels</a:t>
+            </a:r>
+            <a:endParaRPr lang="en-US" sz="1100" dirty="0"/>
+          </a:p>
+        </p:txBody>
+      </p:sp>
+      <p:sp>
+        <p:nvSpPr>
+          <p:cNvPr id="8" name="Text 5"/>
+          <p:cNvSpPr txBox="1"/>
+          <p:nvPr/>
+        </p:nvSpPr>
+        <p:spPr>
+          <a:xfrm>
+            <a:off x="2148840" y="4480560"/>
+            <a:ext cx="1554480" cy="457200"/>
+          </a:xfrm>
+          <a:prstGeom prst="rect">
+            <a:avLst/>
+          </a:prstGeom>
+          <a:noFill/>
+          <a:ln/>
+        </p:spPr>
+        <p:txBody>
+          <a:bodyPr wrap="square" lIns="0" tIns="0" rIns="0" bIns="0" rtlCol="0" anchor="ctr"/>
+          <a:lstStyle/>
+          <a:p>
+            <a:pPr indent="0" marL="0">
+              <a:buNone/>
+            </a:pPr>
+            <a:r>
+              <a:rPr lang="en-US" sz="2400" b="1" dirty="0">
+                <a:solidFill>
+                  <a:srgbClr val="FFBDC5"/>
+                </a:solidFill>
+                <a:latin typeface="Roboto Mono" pitchFamily="34" charset="0"/>
+                <a:ea typeface="Roboto Mono" pitchFamily="34" charset="-122"/>
+                <a:cs typeface="Roboto Mono" pitchFamily="34" charset="-120"/>
+              </a:rPr>
+              <a:t>~40</a:t>
+            </a:r>
+            <a:endParaRPr lang="en-US" sz="2400" dirty="0"/>
+          </a:p>
+        </p:txBody>
+      </p:sp>
+      <p:sp>
+        <p:nvSpPr>
+          <p:cNvPr id="9" name="Text 6"/>
+          <p:cNvSpPr txBox="1"/>
+          <p:nvPr/>
+        </p:nvSpPr>
+        <p:spPr>
+          <a:xfrm>
+            <a:off x="2148840" y="4937760"/>
+            <a:ext cx="1554480" cy="274320"/>
+          </a:xfrm>
+          <a:prstGeom prst="rect">
+            <a:avLst/>
+          </a:prstGeom>
+          <a:noFill/>
+          <a:ln/>
+        </p:spPr>
+        <p:txBody>
+          <a:bodyPr wrap="square" lIns="0" tIns="0" rIns="0" bIns="0" rtlCol="0" anchor="ctr"/>
+          <a:lstStyle/>
+          <a:p>
+            <a:pPr indent="0" marL="0">
+              <a:buNone/>
+            </a:pPr>
+            <a:r>
+              <a:rPr lang="en-US" sz="1100" dirty="0">
+                <a:solidFill>
+                  <a:srgbClr val="AEB8C8"/>
+                </a:solidFill>
+              </a:rPr>
+              <a:t>req / sec under load</a:t>
+            </a:r>
+            <a:endParaRPr lang="en-US" sz="1100" dirty="0"/>
+          </a:p>
+        </p:txBody>
+      </p:sp>
+      <p:sp>
+        <p:nvSpPr>
+          <p:cNvPr id="10" name="Text 7"/>
+          <p:cNvSpPr txBox="1"/>
+          <p:nvPr/>
+        </p:nvSpPr>
+        <p:spPr>
+          <a:xfrm>
+            <a:off x="548640" y="5349240"/>
+            <a:ext cx="1554480" cy="457200"/>
+          </a:xfrm>
+          <a:prstGeom prst="rect">
+            <a:avLst/>
+          </a:prstGeom>
+          <a:noFill/>
+          <a:ln/>
+        </p:spPr>
+        <p:txBody>
+          <a:bodyPr wrap="square" lIns="0" tIns="0" rIns="0" bIns="0" rtlCol="0" anchor="ctr"/>
+          <a:lstStyle/>
+          <a:p>
+            <a:pPr indent="0" marL="0">
+              <a:buNone/>
+            </a:pPr>
+            <a:r>
+              <a:rPr lang="en-US" sz="2400" b="1" dirty="0">
+                <a:solidFill>
+                  <a:srgbClr val="FFBDC5"/>
+                </a:solidFill>
+                <a:latin typeface="Roboto Mono" pitchFamily="34" charset="0"/>
+                <a:ea typeface="Roboto Mono" pitchFamily="34" charset="-122"/>
+                <a:cs typeface="Roboto Mono" pitchFamily="34" charset="-120"/>
+              </a:rPr>
+              <a:t>~10 ms</a:t>
+            </a:r>
+            <a:endParaRPr lang="en-US" sz="2400" dirty="0"/>
+          </a:p>
+        </p:txBody>
+      </p:sp>
+      <p:sp>
+        <p:nvSpPr>
+          <p:cNvPr id="11" name="Text 8"/>
+          <p:cNvSpPr txBox="1"/>
+          <p:nvPr/>
+        </p:nvSpPr>
+        <p:spPr>
+          <a:xfrm>
+            <a:off x="548640" y="5806440"/>
+            <a:ext cx="1554480" cy="274320"/>
+          </a:xfrm>
+          <a:prstGeom prst="rect">
+            <a:avLst/>
+          </a:prstGeom>
+          <a:noFill/>
+          <a:ln/>
+        </p:spPr>
+        <p:txBody>
+          <a:bodyPr wrap="square" lIns="0" tIns="0" rIns="0" bIns="0" rtlCol="0" anchor="ctr"/>
+          <a:lstStyle/>
+          <a:p>
+            <a:pPr indent="0" marL="0">
+              <a:buNone/>
+            </a:pPr>
+            <a:r>
+              <a:rPr lang="en-US" sz="1100" dirty="0">
+                <a:solidFill>
+                  <a:srgbClr val="AEB8C8"/>
+                </a:solidFill>
+              </a:rPr>
+              <a:t>p95 latency</a:t>
+            </a:r>
+            <a:endParaRPr lang="en-US" sz="1100" dirty="0"/>
+          </a:p>
+        </p:txBody>
+      </p:sp>
+      <p:sp>
+        <p:nvSpPr>
+          <p:cNvPr id="12" name="Text 9"/>
+          <p:cNvSpPr txBox="1"/>
+          <p:nvPr/>
+        </p:nvSpPr>
+        <p:spPr>
+          <a:xfrm>
+            <a:off x="2148840" y="5349240"/>
+            <a:ext cx="1554480" cy="457200"/>
+          </a:xfrm>
+          <a:prstGeom prst="rect">
+            <a:avLst/>
+          </a:prstGeom>
+          <a:noFill/>
+          <a:ln/>
+        </p:spPr>
+        <p:txBody>
+          <a:bodyPr wrap="square" lIns="0" tIns="0" rIns="0" bIns="0" rtlCol="0" anchor="ctr"/>
+          <a:lstStyle/>
+          <a:p>
+            <a:pPr indent="0" marL="0">
+              <a:buNone/>
+            </a:pPr>
+            <a:r>
+              <a:rPr lang="en-US" sz="2400" b="1" dirty="0">
+                <a:solidFill>
+                  <a:srgbClr val="4C9DB0"/>
+                </a:solidFill>
+                <a:latin typeface="Roboto Mono" pitchFamily="34" charset="0"/>
+                <a:ea typeface="Roboto Mono" pitchFamily="34" charset="-122"/>
+                <a:cs typeface="Roboto Mono" pitchFamily="34" charset="-120"/>
+              </a:rPr>
+              <a:t>UP</a:t>
+            </a:r>
+            <a:endParaRPr lang="en-US" sz="2400" dirty="0"/>
+          </a:p>
+        </p:txBody>
+      </p:sp>
+      <p:sp>
+        <p:nvSpPr>
+          <p:cNvPr id="13" name="Text 10"/>
+          <p:cNvSpPr txBox="1"/>
+          <p:nvPr/>
+        </p:nvSpPr>
+        <p:spPr>
+          <a:xfrm>
+            <a:off x="2148840" y="5806440"/>
+            <a:ext cx="1554480" cy="274320"/>
+          </a:xfrm>
+          <a:prstGeom prst="rect">
+            <a:avLst/>
+          </a:prstGeom>
+          <a:noFill/>
+          <a:ln/>
+        </p:spPr>
+        <p:txBody>
+          <a:bodyPr wrap="square" lIns="0" tIns="0" rIns="0" bIns="0" rtlCol="0" anchor="ctr"/>
+          <a:lstStyle/>
+          <a:p>
+            <a:pPr indent="0" marL="0">
+              <a:buNone/>
+            </a:pPr>
+            <a:r>
+              <a:rPr lang="en-US" sz="1100" dirty="0">
+                <a:solidFill>
+                  <a:srgbClr val="AEB8C8"/>
+                </a:solidFill>
+              </a:rPr>
+              <a:t>all scrape targets</a:t>
+            </a:r>
+            <a:endParaRPr lang="en-US" sz="1100" dirty="0"/>
+          </a:p>
+        </p:txBody>
+      </p:sp>
+      <p:sp>
+        <p:nvSpPr>
+          <p:cNvPr id="14" name="Browser frame"/>
+          <p:cNvSpPr/>
+          <p:nvPr/>
+        </p:nvSpPr>
+        <p:spPr>
+          <a:xfrm>
+            <a:off x="4087368" y="1453896"/>
+            <a:ext cx="7644384" cy="4626864"/>
+          </a:xfrm>
+          <a:prstGeom prst="roundRect">
+            <a:avLst>
+              <a:gd name="adj" fmla="val 2767"/>
+            </a:avLst>
+          </a:prstGeom>
+          <a:solidFill>
+            <a:srgbClr val="0F1622"/>
+          </a:solidFill>
+          <a:ln w="9525">
+            <a:solidFill>
+              <a:srgbClr val="0F1622"/>
+            </a:solidFill>
+            <a:prstDash val="solid"/>
+          </a:ln>
+          <a:effectLst>
+            <a:outerShdw sx="100000" sy="100000" kx="0" ky="0" algn="bl" rotWithShape="0" blurRad="177800" dist="63500" dir="5400000">
+              <a:srgbClr val="1B1A24">
+                <a:alpha val="16000"/>
+              </a:srgbClr>
+            </a:outerShdw>
+          </a:effectLst>
+        </p:spPr>
+      </p:sp>
+      <p:sp>
+        <p:nvSpPr>
+          <p:cNvPr id="15" name="Window dot"/>
+          <p:cNvSpPr/>
+          <p:nvPr/>
+        </p:nvSpPr>
+        <p:spPr>
+          <a:xfrm>
+            <a:off x="4233672" y="1563624"/>
+            <a:ext cx="109728" cy="109728"/>
+          </a:xfrm>
+          <a:prstGeom prst="ellipse">
+            <a:avLst/>
+          </a:prstGeom>
+          <a:solidFill>
+            <a:srgbClr val="FF5F57"/>
+          </a:solidFill>
+          <a:ln w="12700">
+            <a:solidFill>
+              <a:srgbClr val="FF5F57"/>
+            </a:solidFill>
+            <a:prstDash val="solid"/>
+          </a:ln>
+        </p:spPr>
+      </p:sp>
+      <p:sp>
+        <p:nvSpPr>
+          <p:cNvPr id="16" name="Window dot"/>
+          <p:cNvSpPr/>
+          <p:nvPr/>
+        </p:nvSpPr>
+        <p:spPr>
+          <a:xfrm>
+            <a:off x="4416552" y="1563624"/>
+            <a:ext cx="109728" cy="109728"/>
+          </a:xfrm>
+          <a:prstGeom prst="ellipse">
+            <a:avLst/>
+          </a:prstGeom>
+          <a:solidFill>
+            <a:srgbClr val="FEBC2E"/>
+          </a:solidFill>
+          <a:ln w="12700">
+            <a:solidFill>
+              <a:srgbClr val="FEBC2E"/>
+            </a:solidFill>
+            <a:prstDash val="solid"/>
+          </a:ln>
+        </p:spPr>
+      </p:sp>
+      <p:sp>
+        <p:nvSpPr>
+          <p:cNvPr id="17" name="Window dot"/>
+          <p:cNvSpPr/>
+          <p:nvPr/>
+        </p:nvSpPr>
+        <p:spPr>
+          <a:xfrm>
+            <a:off x="4599432" y="1563624"/>
+            <a:ext cx="109728" cy="109728"/>
+          </a:xfrm>
+          <a:prstGeom prst="ellipse">
+            <a:avLst/>
+          </a:prstGeom>
+          <a:solidFill>
+            <a:srgbClr val="28C840"/>
+          </a:solidFill>
+          <a:ln w="12700">
+            <a:solidFill>
+              <a:srgbClr val="28C840"/>
+            </a:solidFill>
+            <a:prstDash val="solid"/>
+          </a:ln>
+        </p:spPr>
+      </p:sp>
+      <p:pic>
+        <p:nvPicPr>
+          <p:cNvPr id="18" name="Image 1" descr="Screenshot of the running Fellow stack">    </p:cNvPr>
+          <p:cNvPicPr>
+            <a:picLocks noChangeAspect="1"/>
+          </p:cNvPicPr>
+          <p:nvPr/>
+        </p:nvPicPr>
+        <p:blipFill>
+          <a:blip r:embed="rId2"/>
           <a:stretch>
             <a:fillRect/>
           </a:stretch>

</xml_diff>

<commit_message>
docs(demo): correct endpoint count in the deck
</commit_message>
<xml_diff>
--- a/demo/presentation.pptx
+++ b/demo/presentation.pptx
@@ -118,19 +118,19 @@
   <p:extLst>
     <p:ext uri="{521415D9-36F7-43E2-AB2F-B90AF26B5E84}">
       <p14:sectionLst xmlns:p14="http://schemas.microsoft.com/office/powerpoint/2010/main">
-        <p14:section name="Intro" id="{a51aebf7-cf75-fd11-763e-6af36913c8c8}">
+        <p14:section name="Intro" id="{d3ff0235-30a5-dcc6-ef8e-6b3e4d3d6221}">
           <p14:sldIdLst>
             <p14:sldId id="256"/>
             <p14:sldId id="257"/>
           </p14:sldIdLst>
         </p14:section>
-        <p14:section name="Product" id="{81215416-cdc0-9824-b11a-e902a1e92ae8}">
+        <p14:section name="Product" id="{3cdc79c1-50a1-81ec-306c-f97419186d99}">
           <p14:sldIdLst>
             <p14:sldId id="258"/>
             <p14:sldId id="259"/>
           </p14:sldIdLst>
         </p14:section>
-        <p14:section name="Platform" id="{8dab6386-c7f0-2a1b-1293-33d0cce0a436}">
+        <p14:section name="Platform" id="{916d7b4c-caa1-5884-5157-d07c50aa8cf4}">
           <p14:sldIdLst>
             <p14:sldId id="260"/>
             <p14:sldId id="261"/>
@@ -138,13 +138,13 @@
             <p14:sldId id="263"/>
           </p14:sldIdLst>
         </p14:section>
-        <p14:section name="Operate" id="{6716a67f-a58a-74ca-298a-1ebb1b2aac2f}">
+        <p14:section name="Operate" id="{3bd7c58e-180a-a5ab-8a20-f63b4bd5ba54}">
           <p14:sldIdLst>
             <p14:sldId id="264"/>
             <p14:sldId id="265"/>
           </p14:sldIdLst>
         </p14:section>
-        <p14:section name="Wrap up" id="{71517370-95ab-0597-24c6-5846a1cf4bcd}">
+        <p14:section name="Wrap up" id="{f98c5de4-fd26-d780-6c14-376fcf7ed4b9}">
           <p14:sldIdLst>
             <p14:sldId id="266"/>
             <p14:sldId id="267"/>
@@ -5275,7 +5275,7 @@
                 <a:ea typeface="Roboto Mono" pitchFamily="34" charset="-122"/>
                 <a:cs typeface="Roboto Mono" pitchFamily="34" charset="-120"/>
               </a:rPr>
-              <a:t>25</a:t>
+              <a:t>26</a:t>
             </a:r>
             <a:endParaRPr lang="en-US" sz="4400" dirty="0"/>
           </a:p>

</xml_diff>